<commit_message>
Update Charlie- summer 2026 presentation.pptx
</commit_message>
<xml_diff>
--- a/Current Presentation/Charlie- summer 2026 presentation.pptx
+++ b/Current Presentation/Charlie- summer 2026 presentation.pptx
@@ -110,6 +110,14 @@
     </p:ext>
   </p:extLst>
 </p:presentation>
+</file>
+
+<file path=ppt/revisionInfo.xml><?xml version="1.0" encoding="utf-8"?>
+<p1510:revInfo xmlns:a="http://schemas.openxmlformats.org/drawingml/2006/main" xmlns:r="http://schemas.openxmlformats.org/officeDocument/2006/relationships" xmlns:p1510="http://schemas.microsoft.com/office/powerpoint/2015/10/main">
+  <p1510:revLst>
+    <p1510:client id="{43CB8E75-68D2-113B-DE57-B3F75E6001AA}" v="27" dt="2026-09-16T16:25:32.272"/>
+  </p1510:revLst>
+</p1510:revInfo>
 </file>
 
 <file path=ppt/slideLayouts/slideLayout1.xml><?xml version="1.0" encoding="utf-8"?>
@@ -2984,7 +2992,17 @@
           <a:bodyPr/>
           <a:lstStyle/>
           <a:p>
-            <a:endParaRPr lang="en-US"/>
+            <a:r>
+              <a:rPr lang="en-US" dirty="0"/>
+              <a:t>Charlie Hatch</a:t>
+            </a:r>
+            <a:br>
+              <a:rPr lang="en-US" dirty="0"/>
+            </a:br>
+            <a:r>
+              <a:rPr lang="en-US" dirty="0"/>
+              <a:t>Summer term</a:t>
+            </a:r>
           </a:p>
         </p:txBody>
       </p:sp>

</xml_diff>

<commit_message>
Revert "Update Charlie- summer 2026 presentation.pptx"
This reverts commit fa159021dd9f2d5280709b46c97ad8774822ba76.
</commit_message>
<xml_diff>
--- a/Current Presentation/Charlie- summer 2026 presentation.pptx
+++ b/Current Presentation/Charlie- summer 2026 presentation.pptx
@@ -110,14 +110,6 @@
     </p:ext>
   </p:extLst>
 </p:presentation>
-</file>
-
-<file path=ppt/revisionInfo.xml><?xml version="1.0" encoding="utf-8"?>
-<p1510:revInfo xmlns:a="http://schemas.openxmlformats.org/drawingml/2006/main" xmlns:r="http://schemas.openxmlformats.org/officeDocument/2006/relationships" xmlns:p1510="http://schemas.microsoft.com/office/powerpoint/2015/10/main">
-  <p1510:revLst>
-    <p1510:client id="{43CB8E75-68D2-113B-DE57-B3F75E6001AA}" v="27" dt="2026-09-16T16:25:32.272"/>
-  </p1510:revLst>
-</p1510:revInfo>
 </file>
 
 <file path=ppt/slideLayouts/slideLayout1.xml><?xml version="1.0" encoding="utf-8"?>
@@ -2992,17 +2984,7 @@
           <a:bodyPr/>
           <a:lstStyle/>
           <a:p>
-            <a:r>
-              <a:rPr lang="en-US" dirty="0"/>
-              <a:t>Charlie Hatch</a:t>
-            </a:r>
-            <a:br>
-              <a:rPr lang="en-US" dirty="0"/>
-            </a:br>
-            <a:r>
-              <a:rPr lang="en-US" dirty="0"/>
-              <a:t>Summer term</a:t>
-            </a:r>
+            <a:endParaRPr lang="en-US"/>
           </a:p>
         </p:txBody>
       </p:sp>

</xml_diff>

<commit_message>
update presentation to the bsod one
</commit_message>
<xml_diff>
--- a/Current Presentation/Charlie- summer 2026 presentation.pptx
+++ b/Current Presentation/Charlie- summer 2026 presentation.pptx
@@ -120,7 +120,7 @@
 <p1510:revInfo xmlns:a="http://schemas.openxmlformats.org/drawingml/2006/main" xmlns:r="http://schemas.openxmlformats.org/officeDocument/2006/relationships" xmlns:p1510="http://schemas.microsoft.com/office/powerpoint/2015/10/main">
   <p1510:revLst>
     <p1510:client id="{70E034A4-BB94-F8D4-67B6-8AD443040898}" v="40" dt="2026-09-16T19:24:07.670"/>
-    <p1510:client id="{B56F71EC-F6B7-385C-DEBA-57351A51A5CE}" v="13" dt="2026-09-16T19:35:59.011"/>
+    <p1510:client id="{B56F71EC-F6B7-385C-DEBA-57351A51A5CE}" v="9" dt="2026-09-16T19:34:03.414"/>
     <p1510:client id="{CC656977-A51D-85A4-2C0F-8858A80BAC84}" v="271" dt="2026-09-16T17:16:40.811"/>
   </p1510:revLst>
 </p1510:revInfo>
@@ -4935,10 +4935,10 @@
       </p:grpSpPr>
       <p:grpSp>
         <p:nvGrpSpPr>
-          <p:cNvPr id="8" name="Group 7">
+          <p:cNvPr id="5" name="Group 4">
             <a:extLst>
               <a:ext uri="{FF2B5EF4-FFF2-40B4-BE49-F238E27FC236}">
-                <a16:creationId xmlns:a16="http://schemas.microsoft.com/office/drawing/2014/main" id="{40E79D08-6933-85CA-D750-3A34B3FBC381}"/>
+                <a16:creationId xmlns:a16="http://schemas.microsoft.com/office/drawing/2014/main" id="{056AD9B4-FA83-B37A-925D-0FF38465B7AA}"/>
               </a:ext>
             </a:extLst>
           </p:cNvPr>
@@ -4955,10 +4955,10 @@
         </p:grpSpPr>
         <p:sp>
           <p:nvSpPr>
-            <p:cNvPr id="9" name="Rectangle 8">
+            <p:cNvPr id="6" name="Rectangle 5">
               <a:extLst>
                 <a:ext uri="{FF2B5EF4-FFF2-40B4-BE49-F238E27FC236}">
-                  <a16:creationId xmlns:a16="http://schemas.microsoft.com/office/drawing/2014/main" id="{EF9A5C66-D130-5D59-F688-0290BD303654}"/>
+                  <a16:creationId xmlns:a16="http://schemas.microsoft.com/office/drawing/2014/main" id="{3BD51B22-6035-47AA-F096-DF50E1293D3E}"/>
                 </a:ext>
               </a:extLst>
             </p:cNvPr>
@@ -5098,10 +5098,10 @@
         </p:sp>
         <p:pic>
           <p:nvPicPr>
-            <p:cNvPr id="10" name="Picture 9" descr="A blue screen with a qr code&#10;&#10;AI-generated content may be incorrect.">
+            <p:cNvPr id="7" name="Picture 6" descr="A blue screen with a qr code&#10;&#10;AI-generated content may be incorrect.">
               <a:extLst>
                 <a:ext uri="{FF2B5EF4-FFF2-40B4-BE49-F238E27FC236}">
-                  <a16:creationId xmlns:a16="http://schemas.microsoft.com/office/drawing/2014/main" id="{43204064-87A6-92BE-55E2-FCD9052D16A4}"/>
+                  <a16:creationId xmlns:a16="http://schemas.microsoft.com/office/drawing/2014/main" id="{093AC10B-ECC1-A72C-BD4E-BE5469028DD3}"/>
                 </a:ext>
               </a:extLst>
             </p:cNvPr>

</xml_diff>